<commit_message>
Publish the TextMate grammar as GermannM3/kenga-grammar and rebuild the language pitch.
GitHub still will not list .kenga until Linguist sees enough foreign usage; the grammar URL is ready.

Co-authored-by: Cursor <cursoragent@cursor.com>
</commit_message>
<xml_diff>
--- a/sell/kenga-language/pitch.en.pptx
+++ b/sell/kenga-language/pitch.en.pptx
@@ -15,6 +15,7 @@
     <p:sldId id="263" r:id="rId15"/>
     <p:sldId id="264" r:id="rId16"/>
     <p:sldId id="265" r:id="rId17"/>
+    <p:sldId id="266" r:id="rId18"/>
   </p:sldIdLst>
   <p:sldSz cx="12191695" cy="6858000" type="screen4x3"/>
   <p:notesSz cx="6858000" cy="9144000"/>
@@ -581,6 +582,76 @@
           <a:lstStyle/>
           <a:p>
             <a:r>
+              <a:t>Do not negotiate a license blind. Ask what subset they would bring to a pilot. No subset, no partnership yet.</a:t>
+            </a:r>
+          </a:p>
+        </p:txBody>
+      </p:sp>
+      <p:sp>
+        <p:nvSpPr>
+          <p:cNvPr id="4" name="Slide Number Placeholder 3"/>
+          <p:cNvSpPr>
+            <a:spLocks noGrp="1"/>
+          </p:cNvSpPr>
+          <p:nvPr>
+            <p:ph type="sldNum" idx="5" sz="quarter"/>
+          </p:nvPr>
+        </p:nvSpPr>
+        <p:spPr/>
+      </p:sp>
+    </p:spTree>
+  </p:cSld>
+  <p:clrMapOvr>
+    <a:masterClrMapping/>
+  </p:clrMapOvr>
+</p:notes>
+</file>
+
+<file path=ppt/notesSlides/notesSlide11.xml><?xml version="1.0" encoding="utf-8"?>
+<p:notes xmlns:a="http://schemas.openxmlformats.org/drawingml/2006/main" xmlns:p="http://schemas.openxmlformats.org/presentationml/2006/main" xmlns:r="http://schemas.openxmlformats.org/officeDocument/2006/relationships">
+  <p:cSld>
+    <p:spTree>
+      <p:nvGrpSpPr>
+        <p:cNvPr id="1" name=""/>
+        <p:cNvGrpSpPr/>
+        <p:nvPr/>
+      </p:nvGrpSpPr>
+      <p:grpSpPr>
+        <a:xfrm>
+          <a:off x="0" y="0"/>
+          <a:ext cx="0" cy="0"/>
+          <a:chOff x="0" y="0"/>
+          <a:chExt cx="0" cy="0"/>
+        </a:xfrm>
+      </p:grpSpPr>
+      <p:sp>
+        <p:nvSpPr>
+          <p:cNvPr id="2" name="Slide Image Placeholder 1"/>
+          <p:cNvSpPr>
+            <a:spLocks noGrp="1"/>
+          </p:cNvSpPr>
+          <p:nvPr>
+            <p:ph type="sldImg" idx="2"/>
+          </p:nvPr>
+        </p:nvSpPr>
+        <p:spPr/>
+      </p:sp>
+      <p:sp>
+        <p:nvSpPr>
+          <p:cNvPr id="3" name="Notes Placeholder 2"/>
+          <p:cNvSpPr>
+            <a:spLocks noGrp="1"/>
+          </p:cNvSpPr>
+          <p:nvPr>
+            <p:ph type="body" idx="3" sz="quarter"/>
+          </p:nvPr>
+        </p:nvSpPr>
+        <p:spPr/>
+        <p:txBody>
+          <a:bodyPr/>
+          <a:lstStyle/>
+          <a:p>
+            <a:r>
               <a:t>One ask: 30 minutes with their compiler or runtime lead. Do not say sometime. Put a date in the email, not on this slide.</a:t>
             </a:r>
           </a:p>
@@ -1071,7 +1142,7 @@
           <a:lstStyle/>
           <a:p>
             <a:r>
-              <a:t>Read the five lines as written. Windows cmd. MSVC or gcc. Do not paraphrase the paths. If they are on Unix, FOR_FRIENDS.md mentions unix-smoke; this slide is the cmd sequence.</a:t>
+              <a:t>Do not promise github.com highlighting tomorrow. If they ask when: when other people publish .kenga, not when we push the grammar again.</a:t>
             </a:r>
           </a:p>
         </p:txBody>
@@ -1141,7 +1212,7 @@
           <a:lstStyle/>
           <a:p>
             <a:r>
-              <a:t>Do not negotiate a license blind. Ask what subset they would bring to a pilot. No subset, no partnership yet.</a:t>
+              <a:t>Read the five lines as written. Windows cmd. MSVC or gcc. Do not paraphrase the paths. If they are on Unix, FOR_FRIENDS.md mentions unix-smoke; this slide is the cmd sequence.</a:t>
             </a:r>
           </a:p>
         </p:txBody>
@@ -4584,7 +4655,7 @@
                 <a:latin typeface="Calibri"/>
                 <a:ea typeface="Calibri"/>
               </a:rPr>
-              <a:t>NEXT</a:t>
+              <a:t>OFFER</a:t>
             </a:r>
           </a:p>
         </p:txBody>
@@ -4620,7 +4691,7 @@
                 <a:latin typeface="Calibri"/>
                 <a:ea typeface="Calibri"/>
               </a:rPr>
-              <a:t>Thirty minutes with whoever owns the compiler</a:t>
+              <a:t>License, four weeks, the host</a:t>
             </a:r>
           </a:p>
         </p:txBody>
@@ -4699,7 +4770,7 @@
                 <a:latin typeface="Calibri"/>
                 <a:ea typeface="Calibri"/>
               </a:rPr>
-              <a:t>Three pptx files are in this folder, next to the letter.</a:t>
+              <a:t>License the stack, or acquire it.</a:t>
             </a:r>
           </a:p>
         </p:txBody>
@@ -4778,7 +4849,7 @@
                 <a:latin typeface="Calibri"/>
                 <a:ea typeface="Calibri"/>
               </a:rPr>
-              <a:t>Repo: github.com/GermannM3/kenga-lang</a:t>
+              <a:t>A 4-week embed: you bring a language subset, we show compile and run on your machine.</a:t>
             </a:r>
           </a:p>
         </p:txBody>
@@ -4857,7 +4928,7 @@
                 <a:latin typeface="Calibri"/>
                 <a:ea typeface="Calibri"/>
               </a:rPr>
-              <a:t>I want 30 minutes with the person who owns your compiler or runtime.</a:t>
+              <a:t>An engineering partnership to replace more of the C host.</a:t>
             </a:r>
           </a:p>
         </p:txBody>
@@ -4936,7 +5007,7 @@
                 <a:latin typeface="Calibri"/>
                 <a:ea typeface="Calibri"/>
               </a:rPr>
-              <a:t>If you clone, run freedom-smoke, and it is boring, say so. That counts as an answer.</a:t>
+              <a:t>The repo is already MIT. You pay for embed, for ownership, and for the remaining host work.</a:t>
             </a:r>
           </a:p>
         </p:txBody>
@@ -5008,7 +5079,571 @@
                 <a:latin typeface="Calibri"/>
                 <a:ea typeface="Calibri"/>
               </a:rPr>
-              <a:t>10 / 10</a:t>
+              <a:t>10 / 11</a:t>
+            </a:r>
+          </a:p>
+        </p:txBody>
+      </p:sp>
+    </p:spTree>
+  </p:cSld>
+  <p:clrMapOvr>
+    <a:masterClrMapping/>
+  </p:clrMapOvr>
+</p:sld>
+</file>
+
+<file path=ppt/slides/slide11.xml><?xml version="1.0" encoding="utf-8"?>
+<p:sld xmlns:a="http://schemas.openxmlformats.org/drawingml/2006/main" xmlns:p="http://schemas.openxmlformats.org/presentationml/2006/main" xmlns:r="http://schemas.openxmlformats.org/officeDocument/2006/relationships">
+  <p:cSld>
+    <p:spTree>
+      <p:nvGrpSpPr>
+        <p:cNvPr id="1" name=""/>
+        <p:cNvGrpSpPr/>
+        <p:nvPr/>
+      </p:nvGrpSpPr>
+      <p:grpSpPr/>
+      <p:sp>
+        <p:nvSpPr>
+          <p:cNvPr id="2" name="Rectangle 1"/>
+          <p:cNvSpPr/>
+          <p:nvPr/>
+        </p:nvSpPr>
+        <p:spPr>
+          <a:xfrm>
+            <a:off x="0" y="0"/>
+            <a:ext cx="12191695" cy="6858000"/>
+          </a:xfrm>
+          <a:prstGeom prst="rect">
+            <a:avLst/>
+          </a:prstGeom>
+          <a:solidFill>
+            <a:srgbClr val="F4F0E6"/>
+          </a:solidFill>
+          <a:ln>
+            <a:noFill/>
+          </a:ln>
+        </p:spPr>
+        <p:style>
+          <a:lnRef idx="1">
+            <a:schemeClr val="accent1"/>
+          </a:lnRef>
+          <a:fillRef idx="3">
+            <a:schemeClr val="accent1"/>
+          </a:fillRef>
+          <a:effectRef idx="2">
+            <a:schemeClr val="accent1"/>
+          </a:effectRef>
+          <a:fontRef idx="minor">
+            <a:schemeClr val="lt1"/>
+          </a:fontRef>
+        </p:style>
+        <p:txBody>
+          <a:bodyPr rtlCol="0" anchor="ctr"/>
+          <a:lstStyle/>
+          <a:p>
+            <a:pPr algn="ctr"/>
+          </a:p>
+        </p:txBody>
+      </p:sp>
+      <p:sp>
+        <p:nvSpPr>
+          <p:cNvPr id="3" name="Rectangle 2"/>
+          <p:cNvSpPr/>
+          <p:nvPr/>
+        </p:nvSpPr>
+        <p:spPr>
+          <a:xfrm>
+            <a:off x="0" y="0"/>
+            <a:ext cx="109728" cy="6858000"/>
+          </a:xfrm>
+          <a:prstGeom prst="rect">
+            <a:avLst/>
+          </a:prstGeom>
+          <a:solidFill>
+            <a:srgbClr val="C45C26"/>
+          </a:solidFill>
+          <a:ln>
+            <a:noFill/>
+          </a:ln>
+        </p:spPr>
+        <p:style>
+          <a:lnRef idx="1">
+            <a:schemeClr val="accent1"/>
+          </a:lnRef>
+          <a:fillRef idx="3">
+            <a:schemeClr val="accent1"/>
+          </a:fillRef>
+          <a:effectRef idx="2">
+            <a:schemeClr val="accent1"/>
+          </a:effectRef>
+          <a:fontRef idx="minor">
+            <a:schemeClr val="lt1"/>
+          </a:fontRef>
+        </p:style>
+        <p:txBody>
+          <a:bodyPr rtlCol="0" anchor="ctr"/>
+          <a:lstStyle/>
+          <a:p>
+            <a:pPr algn="ctr"/>
+          </a:p>
+        </p:txBody>
+      </p:sp>
+      <p:sp>
+        <p:nvSpPr>
+          <p:cNvPr id="4" name="TextBox 3"/>
+          <p:cNvSpPr txBox="1"/>
+          <p:nvPr/>
+        </p:nvSpPr>
+        <p:spPr>
+          <a:xfrm>
+            <a:off x="640080" y="320040"/>
+            <a:ext cx="10058400" cy="320040"/>
+          </a:xfrm>
+          <a:prstGeom prst="rect">
+            <a:avLst/>
+          </a:prstGeom>
+          <a:noFill/>
+        </p:spPr>
+        <p:txBody>
+          <a:bodyPr wrap="square">
+            <a:spAutoFit/>
+          </a:bodyPr>
+          <a:lstStyle/>
+          <a:p>
+            <a:pPr algn="l"/>
+            <a:r>
+              <a:rPr sz="1200" b="1">
+                <a:solidFill>
+                  <a:srgbClr val="C45C26"/>
+                </a:solidFill>
+                <a:latin typeface="Calibri"/>
+                <a:ea typeface="Calibri"/>
+              </a:rPr>
+              <a:t>NEXT</a:t>
+            </a:r>
+          </a:p>
+        </p:txBody>
+      </p:sp>
+      <p:sp>
+        <p:nvSpPr>
+          <p:cNvPr id="5" name="TextBox 4"/>
+          <p:cNvSpPr txBox="1"/>
+          <p:nvPr/>
+        </p:nvSpPr>
+        <p:spPr>
+          <a:xfrm>
+            <a:off x="640080" y="640080"/>
+            <a:ext cx="10972800" cy="1005840"/>
+          </a:xfrm>
+          <a:prstGeom prst="rect">
+            <a:avLst/>
+          </a:prstGeom>
+          <a:noFill/>
+        </p:spPr>
+        <p:txBody>
+          <a:bodyPr wrap="square">
+            <a:spAutoFit/>
+          </a:bodyPr>
+          <a:lstStyle/>
+          <a:p>
+            <a:pPr algn="l"/>
+            <a:r>
+              <a:rPr sz="2800" b="1">
+                <a:solidFill>
+                  <a:srgbClr val="1A1814"/>
+                </a:solidFill>
+                <a:latin typeface="Calibri"/>
+                <a:ea typeface="Calibri"/>
+              </a:rPr>
+              <a:t>Thirty minutes with whoever owns the compiler</a:t>
+            </a:r>
+          </a:p>
+        </p:txBody>
+      </p:sp>
+      <p:sp>
+        <p:nvSpPr>
+          <p:cNvPr id="6" name="Rectangle 5"/>
+          <p:cNvSpPr/>
+          <p:nvPr/>
+        </p:nvSpPr>
+        <p:spPr>
+          <a:xfrm>
+            <a:off x="640080" y="1984248"/>
+            <a:ext cx="109728" cy="109728"/>
+          </a:xfrm>
+          <a:prstGeom prst="rect">
+            <a:avLst/>
+          </a:prstGeom>
+          <a:solidFill>
+            <a:srgbClr val="C45C26"/>
+          </a:solidFill>
+          <a:ln>
+            <a:noFill/>
+          </a:ln>
+        </p:spPr>
+        <p:style>
+          <a:lnRef idx="1">
+            <a:schemeClr val="accent1"/>
+          </a:lnRef>
+          <a:fillRef idx="3">
+            <a:schemeClr val="accent1"/>
+          </a:fillRef>
+          <a:effectRef idx="2">
+            <a:schemeClr val="accent1"/>
+          </a:effectRef>
+          <a:fontRef idx="minor">
+            <a:schemeClr val="lt1"/>
+          </a:fontRef>
+        </p:style>
+        <p:txBody>
+          <a:bodyPr rtlCol="0" anchor="ctr"/>
+          <a:lstStyle/>
+          <a:p>
+            <a:pPr algn="ctr"/>
+          </a:p>
+        </p:txBody>
+      </p:sp>
+      <p:sp>
+        <p:nvSpPr>
+          <p:cNvPr id="7" name="TextBox 6"/>
+          <p:cNvSpPr txBox="1"/>
+          <p:nvPr/>
+        </p:nvSpPr>
+        <p:spPr>
+          <a:xfrm>
+            <a:off x="960120" y="1874519"/>
+            <a:ext cx="10424160" cy="777240"/>
+          </a:xfrm>
+          <a:prstGeom prst="rect">
+            <a:avLst/>
+          </a:prstGeom>
+          <a:noFill/>
+        </p:spPr>
+        <p:txBody>
+          <a:bodyPr wrap="square">
+            <a:spAutoFit/>
+          </a:bodyPr>
+          <a:lstStyle/>
+          <a:p>
+            <a:pPr algn="l"/>
+            <a:r>
+              <a:rPr sz="1800" b="0">
+                <a:solidFill>
+                  <a:srgbClr val="1A1814"/>
+                </a:solidFill>
+                <a:latin typeface="Calibri"/>
+                <a:ea typeface="Calibri"/>
+              </a:rPr>
+              <a:t>Three pptx files are in this folder, next to the letter.</a:t>
+            </a:r>
+          </a:p>
+        </p:txBody>
+      </p:sp>
+      <p:sp>
+        <p:nvSpPr>
+          <p:cNvPr id="8" name="Rectangle 7"/>
+          <p:cNvSpPr/>
+          <p:nvPr/>
+        </p:nvSpPr>
+        <p:spPr>
+          <a:xfrm>
+            <a:off x="640080" y="2697480"/>
+            <a:ext cx="109728" cy="109728"/>
+          </a:xfrm>
+          <a:prstGeom prst="rect">
+            <a:avLst/>
+          </a:prstGeom>
+          <a:solidFill>
+            <a:srgbClr val="C45C26"/>
+          </a:solidFill>
+          <a:ln>
+            <a:noFill/>
+          </a:ln>
+        </p:spPr>
+        <p:style>
+          <a:lnRef idx="1">
+            <a:schemeClr val="accent1"/>
+          </a:lnRef>
+          <a:fillRef idx="3">
+            <a:schemeClr val="accent1"/>
+          </a:fillRef>
+          <a:effectRef idx="2">
+            <a:schemeClr val="accent1"/>
+          </a:effectRef>
+          <a:fontRef idx="minor">
+            <a:schemeClr val="lt1"/>
+          </a:fontRef>
+        </p:style>
+        <p:txBody>
+          <a:bodyPr rtlCol="0" anchor="ctr"/>
+          <a:lstStyle/>
+          <a:p>
+            <a:pPr algn="ctr"/>
+          </a:p>
+        </p:txBody>
+      </p:sp>
+      <p:sp>
+        <p:nvSpPr>
+          <p:cNvPr id="9" name="TextBox 8"/>
+          <p:cNvSpPr txBox="1"/>
+          <p:nvPr/>
+        </p:nvSpPr>
+        <p:spPr>
+          <a:xfrm>
+            <a:off x="960120" y="2587752"/>
+            <a:ext cx="10424160" cy="777240"/>
+          </a:xfrm>
+          <a:prstGeom prst="rect">
+            <a:avLst/>
+          </a:prstGeom>
+          <a:noFill/>
+        </p:spPr>
+        <p:txBody>
+          <a:bodyPr wrap="square">
+            <a:spAutoFit/>
+          </a:bodyPr>
+          <a:lstStyle/>
+          <a:p>
+            <a:pPr algn="l"/>
+            <a:r>
+              <a:rPr sz="1800" b="0">
+                <a:solidFill>
+                  <a:srgbClr val="1A1814"/>
+                </a:solidFill>
+                <a:latin typeface="Calibri"/>
+                <a:ea typeface="Calibri"/>
+              </a:rPr>
+              <a:t>Repo: github.com/GermannM3/kenga-lang</a:t>
+            </a:r>
+          </a:p>
+        </p:txBody>
+      </p:sp>
+      <p:sp>
+        <p:nvSpPr>
+          <p:cNvPr id="10" name="Rectangle 9"/>
+          <p:cNvSpPr/>
+          <p:nvPr/>
+        </p:nvSpPr>
+        <p:spPr>
+          <a:xfrm>
+            <a:off x="640080" y="3410712"/>
+            <a:ext cx="109728" cy="109728"/>
+          </a:xfrm>
+          <a:prstGeom prst="rect">
+            <a:avLst/>
+          </a:prstGeom>
+          <a:solidFill>
+            <a:srgbClr val="C45C26"/>
+          </a:solidFill>
+          <a:ln>
+            <a:noFill/>
+          </a:ln>
+        </p:spPr>
+        <p:style>
+          <a:lnRef idx="1">
+            <a:schemeClr val="accent1"/>
+          </a:lnRef>
+          <a:fillRef idx="3">
+            <a:schemeClr val="accent1"/>
+          </a:fillRef>
+          <a:effectRef idx="2">
+            <a:schemeClr val="accent1"/>
+          </a:effectRef>
+          <a:fontRef idx="minor">
+            <a:schemeClr val="lt1"/>
+          </a:fontRef>
+        </p:style>
+        <p:txBody>
+          <a:bodyPr rtlCol="0" anchor="ctr"/>
+          <a:lstStyle/>
+          <a:p>
+            <a:pPr algn="ctr"/>
+          </a:p>
+        </p:txBody>
+      </p:sp>
+      <p:sp>
+        <p:nvSpPr>
+          <p:cNvPr id="11" name="TextBox 10"/>
+          <p:cNvSpPr txBox="1"/>
+          <p:nvPr/>
+        </p:nvSpPr>
+        <p:spPr>
+          <a:xfrm>
+            <a:off x="960120" y="3300984"/>
+            <a:ext cx="10424160" cy="777240"/>
+          </a:xfrm>
+          <a:prstGeom prst="rect">
+            <a:avLst/>
+          </a:prstGeom>
+          <a:noFill/>
+        </p:spPr>
+        <p:txBody>
+          <a:bodyPr wrap="square">
+            <a:spAutoFit/>
+          </a:bodyPr>
+          <a:lstStyle/>
+          <a:p>
+            <a:pPr algn="l"/>
+            <a:r>
+              <a:rPr sz="1800" b="0">
+                <a:solidFill>
+                  <a:srgbClr val="1A1814"/>
+                </a:solidFill>
+                <a:latin typeface="Calibri"/>
+                <a:ea typeface="Calibri"/>
+              </a:rPr>
+              <a:t>I want 30 minutes with the person who owns your compiler or runtime.</a:t>
+            </a:r>
+          </a:p>
+        </p:txBody>
+      </p:sp>
+      <p:sp>
+        <p:nvSpPr>
+          <p:cNvPr id="12" name="Rectangle 11"/>
+          <p:cNvSpPr/>
+          <p:nvPr/>
+        </p:nvSpPr>
+        <p:spPr>
+          <a:xfrm>
+            <a:off x="640080" y="4123944"/>
+            <a:ext cx="109728" cy="109728"/>
+          </a:xfrm>
+          <a:prstGeom prst="rect">
+            <a:avLst/>
+          </a:prstGeom>
+          <a:solidFill>
+            <a:srgbClr val="C45C26"/>
+          </a:solidFill>
+          <a:ln>
+            <a:noFill/>
+          </a:ln>
+        </p:spPr>
+        <p:style>
+          <a:lnRef idx="1">
+            <a:schemeClr val="accent1"/>
+          </a:lnRef>
+          <a:fillRef idx="3">
+            <a:schemeClr val="accent1"/>
+          </a:fillRef>
+          <a:effectRef idx="2">
+            <a:schemeClr val="accent1"/>
+          </a:effectRef>
+          <a:fontRef idx="minor">
+            <a:schemeClr val="lt1"/>
+          </a:fontRef>
+        </p:style>
+        <p:txBody>
+          <a:bodyPr rtlCol="0" anchor="ctr"/>
+          <a:lstStyle/>
+          <a:p>
+            <a:pPr algn="ctr"/>
+          </a:p>
+        </p:txBody>
+      </p:sp>
+      <p:sp>
+        <p:nvSpPr>
+          <p:cNvPr id="13" name="TextBox 12"/>
+          <p:cNvSpPr txBox="1"/>
+          <p:nvPr/>
+        </p:nvSpPr>
+        <p:spPr>
+          <a:xfrm>
+            <a:off x="960120" y="4014216"/>
+            <a:ext cx="10424160" cy="777240"/>
+          </a:xfrm>
+          <a:prstGeom prst="rect">
+            <a:avLst/>
+          </a:prstGeom>
+          <a:noFill/>
+        </p:spPr>
+        <p:txBody>
+          <a:bodyPr wrap="square">
+            <a:spAutoFit/>
+          </a:bodyPr>
+          <a:lstStyle/>
+          <a:p>
+            <a:pPr algn="l"/>
+            <a:r>
+              <a:rPr sz="1800" b="0">
+                <a:solidFill>
+                  <a:srgbClr val="1A1814"/>
+                </a:solidFill>
+                <a:latin typeface="Calibri"/>
+                <a:ea typeface="Calibri"/>
+              </a:rPr>
+              <a:t>If you clone, run freedom-smoke, and it is boring, say so. That counts as an answer.</a:t>
+            </a:r>
+          </a:p>
+        </p:txBody>
+      </p:sp>
+      <p:sp>
+        <p:nvSpPr>
+          <p:cNvPr id="14" name="TextBox 13"/>
+          <p:cNvSpPr txBox="1"/>
+          <p:nvPr/>
+        </p:nvSpPr>
+        <p:spPr>
+          <a:xfrm>
+            <a:off x="640080" y="6446520"/>
+            <a:ext cx="9144000" cy="274320"/>
+          </a:xfrm>
+          <a:prstGeom prst="rect">
+            <a:avLst/>
+          </a:prstGeom>
+          <a:noFill/>
+        </p:spPr>
+        <p:txBody>
+          <a:bodyPr wrap="square">
+            <a:spAutoFit/>
+          </a:bodyPr>
+          <a:lstStyle/>
+          <a:p>
+            <a:pPr algn="l"/>
+            <a:r>
+              <a:rPr sz="1100" b="0">
+                <a:solidFill>
+                  <a:srgbClr val="6A6256"/>
+                </a:solidFill>
+                <a:latin typeface="Calibri"/>
+                <a:ea typeface="Calibri"/>
+              </a:rPr>
+              <a:t>Kenga | not a press kit | numbers from the repo only</a:t>
+            </a:r>
+          </a:p>
+        </p:txBody>
+      </p:sp>
+      <p:sp>
+        <p:nvSpPr>
+          <p:cNvPr id="15" name="TextBox 14"/>
+          <p:cNvSpPr txBox="1"/>
+          <p:nvPr/>
+        </p:nvSpPr>
+        <p:spPr>
+          <a:xfrm>
+            <a:off x="10607040" y="6446520"/>
+            <a:ext cx="1188720" cy="274320"/>
+          </a:xfrm>
+          <a:prstGeom prst="rect">
+            <a:avLst/>
+          </a:prstGeom>
+          <a:noFill/>
+        </p:spPr>
+        <p:txBody>
+          <a:bodyPr wrap="square">
+            <a:spAutoFit/>
+          </a:bodyPr>
+          <a:lstStyle/>
+          <a:p>
+            <a:pPr algn="r"/>
+            <a:r>
+              <a:rPr sz="1100" b="0">
+                <a:solidFill>
+                  <a:srgbClr val="6A6256"/>
+                </a:solidFill>
+                <a:latin typeface="Calibri"/>
+                <a:ea typeface="Calibri"/>
+              </a:rPr>
+              <a:t>11 / 11</a:t>
             </a:r>
           </a:p>
         </p:txBody>
@@ -5572,7 +6207,7 @@
                 <a:latin typeface="Calibri"/>
                 <a:ea typeface="Calibri"/>
               </a:rPr>
-              <a:t>2 / 10</a:t>
+              <a:t>2 / 11</a:t>
             </a:r>
           </a:p>
         </p:txBody>
@@ -6136,7 +6771,7 @@
                 <a:latin typeface="Calibri"/>
                 <a:ea typeface="Calibri"/>
               </a:rPr>
-              <a:t>3 / 10</a:t>
+              <a:t>3 / 11</a:t>
             </a:r>
           </a:p>
         </p:txBody>
@@ -6700,7 +7335,7 @@
                 <a:latin typeface="Calibri"/>
                 <a:ea typeface="Calibri"/>
               </a:rPr>
-              <a:t>4 / 10</a:t>
+              <a:t>4 / 11</a:t>
             </a:r>
           </a:p>
         </p:txBody>
@@ -7264,7 +7899,7 @@
                 <a:latin typeface="Calibri"/>
                 <a:ea typeface="Calibri"/>
               </a:rPr>
-              <a:t>5 / 10</a:t>
+              <a:t>5 / 11</a:t>
             </a:r>
           </a:p>
         </p:txBody>
@@ -7828,7 +8463,7 @@
                 <a:latin typeface="Calibri"/>
                 <a:ea typeface="Calibri"/>
               </a:rPr>
-              <a:t>6 / 10</a:t>
+              <a:t>6 / 11</a:t>
             </a:r>
           </a:p>
         </p:txBody>
@@ -8392,7 +9027,7 @@
                 <a:latin typeface="Calibri"/>
                 <a:ea typeface="Calibri"/>
               </a:rPr>
-              <a:t>7 / 10</a:t>
+              <a:t>7 / 11</a:t>
             </a:r>
           </a:p>
         </p:txBody>
@@ -8532,7 +9167,7 @@
                 <a:latin typeface="Calibri"/>
                 <a:ea typeface="Calibri"/>
               </a:rPr>
-              <a:t>REPRODUCE</a:t>
+              <a:t>GITHUB</a:t>
             </a:r>
           </a:p>
         </p:txBody>
@@ -8546,7 +9181,7 @@
         <p:spPr>
           <a:xfrm>
             <a:off x="640080" y="640080"/>
-            <a:ext cx="10972800" cy="822960"/>
+            <a:ext cx="10972800" cy="1005840"/>
           </a:xfrm>
           <a:prstGeom prst="rect">
             <a:avLst/>
@@ -8568,27 +9203,27 @@
                 <a:latin typeface="Calibri"/>
                 <a:ea typeface="Calibri"/>
               </a:rPr>
-              <a:t>Clone, build, run</a:t>
-            </a:r>
-          </a:p>
-        </p:txBody>
-      </p:sp>
-      <p:sp>
-        <p:nvSpPr>
-          <p:cNvPr id="6" name="Rounded Rectangle 5"/>
+              <a:t>The grammar is up. Linguist is not</a:t>
+            </a:r>
+          </a:p>
+        </p:txBody>
+      </p:sp>
+      <p:sp>
+        <p:nvSpPr>
+          <p:cNvPr id="6" name="Rectangle 5"/>
           <p:cNvSpPr/>
           <p:nvPr/>
         </p:nvSpPr>
         <p:spPr>
           <a:xfrm>
-            <a:off x="640080" y="1645920"/>
-            <a:ext cx="10881360" cy="4297680"/>
-          </a:xfrm>
-          <a:prstGeom prst="roundRect">
+            <a:off x="640080" y="1984248"/>
+            <a:ext cx="109728" cy="109728"/>
+          </a:xfrm>
+          <a:prstGeom prst="rect">
             <a:avLst/>
           </a:prstGeom>
           <a:solidFill>
-            <a:srgbClr val="1A1814"/>
+            <a:srgbClr val="C45C26"/>
           </a:solidFill>
           <a:ln>
             <a:noFill/>
@@ -8624,8 +9259,8 @@
         </p:nvSpPr>
         <p:spPr>
           <a:xfrm>
-            <a:off x="914400" y="1874519"/>
-            <a:ext cx="10332720" cy="3931920"/>
+            <a:off x="960120" y="1874519"/>
+            <a:ext cx="10424160" cy="777240"/>
           </a:xfrm>
           <a:prstGeom prst="rect">
             <a:avLst/>
@@ -8638,95 +9273,260 @@
           </a:bodyPr>
           <a:lstStyle/>
           <a:p>
-            <a:pPr>
-              <a:spcAft>
-                <a:spcPts val="800"/>
-              </a:spcAft>
-            </a:pPr>
-            <a:r>
-              <a:rPr sz="1600" b="0">
-                <a:solidFill>
-                  <a:srgbClr val="E8E0D0"/>
-                </a:solidFill>
-                <a:latin typeface="Consolas"/>
+            <a:pPr algn="l"/>
+            <a:r>
+              <a:rPr sz="1800" b="0">
+                <a:solidFill>
+                  <a:srgbClr val="1A1814"/>
+                </a:solidFill>
+                <a:latin typeface="Calibri"/>
                 <a:ea typeface="Calibri"/>
               </a:rPr>
-              <a:t>git clone https://github.com/GermannM3/kenga-lang.git</a:t>
-            </a:r>
-          </a:p>
-          <a:p>
-            <a:pPr>
-              <a:spcAft>
-                <a:spcPts val="800"/>
-              </a:spcAft>
-            </a:pPr>
-            <a:r>
-              <a:rPr sz="1600" b="0">
-                <a:solidFill>
-                  <a:srgbClr val="E8E0D0"/>
-                </a:solidFill>
-                <a:latin typeface="Consolas"/>
+              <a:t>Editor highlighting is the Marketplace VSIX 3.13.0. That is not github.com.</a:t>
+            </a:r>
+          </a:p>
+        </p:txBody>
+      </p:sp>
+      <p:sp>
+        <p:nvSpPr>
+          <p:cNvPr id="8" name="Rectangle 7"/>
+          <p:cNvSpPr/>
+          <p:nvPr/>
+        </p:nvSpPr>
+        <p:spPr>
+          <a:xfrm>
+            <a:off x="640080" y="2697480"/>
+            <a:ext cx="109728" cy="109728"/>
+          </a:xfrm>
+          <a:prstGeom prst="rect">
+            <a:avLst/>
+          </a:prstGeom>
+          <a:solidFill>
+            <a:srgbClr val="C45C26"/>
+          </a:solidFill>
+          <a:ln>
+            <a:noFill/>
+          </a:ln>
+        </p:spPr>
+        <p:style>
+          <a:lnRef idx="1">
+            <a:schemeClr val="accent1"/>
+          </a:lnRef>
+          <a:fillRef idx="3">
+            <a:schemeClr val="accent1"/>
+          </a:fillRef>
+          <a:effectRef idx="2">
+            <a:schemeClr val="accent1"/>
+          </a:effectRef>
+          <a:fontRef idx="minor">
+            <a:schemeClr val="lt1"/>
+          </a:fontRef>
+        </p:style>
+        <p:txBody>
+          <a:bodyPr rtlCol="0" anchor="ctr"/>
+          <a:lstStyle/>
+          <a:p>
+            <a:pPr algn="ctr"/>
+          </a:p>
+        </p:txBody>
+      </p:sp>
+      <p:sp>
+        <p:nvSpPr>
+          <p:cNvPr id="9" name="TextBox 8"/>
+          <p:cNvSpPr txBox="1"/>
+          <p:nvPr/>
+        </p:nvSpPr>
+        <p:spPr>
+          <a:xfrm>
+            <a:off x="960120" y="2587752"/>
+            <a:ext cx="10424160" cy="777240"/>
+          </a:xfrm>
+          <a:prstGeom prst="rect">
+            <a:avLst/>
+          </a:prstGeom>
+          <a:noFill/>
+        </p:spPr>
+        <p:txBody>
+          <a:bodyPr wrap="square">
+            <a:spAutoFit/>
+          </a:bodyPr>
+          <a:lstStyle/>
+          <a:p>
+            <a:pPr algn="l"/>
+            <a:r>
+              <a:rPr sz="1800" b="0">
+                <a:solidFill>
+                  <a:srgbClr val="1A1814"/>
+                </a:solidFill>
+                <a:latin typeface="Calibri"/>
                 <a:ea typeface="Calibri"/>
               </a:rPr>
-              <a:t>cd kenga-lang</a:t>
-            </a:r>
-          </a:p>
-          <a:p>
-            <a:pPr>
-              <a:spcAft>
-                <a:spcPts val="800"/>
-              </a:spcAft>
-            </a:pPr>
-            <a:r>
-              <a:rPr sz="1600" b="0">
-                <a:solidFill>
-                  <a:srgbClr val="E8E0D0"/>
-                </a:solidFill>
-                <a:latin typeface="Consolas"/>
+              <a:t>TextMate grammar: github.com/GermannM3/kenga-grammar (MIT, source.kenga).</a:t>
+            </a:r>
+          </a:p>
+        </p:txBody>
+      </p:sp>
+      <p:sp>
+        <p:nvSpPr>
+          <p:cNvPr id="10" name="Rectangle 9"/>
+          <p:cNvSpPr/>
+          <p:nvPr/>
+        </p:nvSpPr>
+        <p:spPr>
+          <a:xfrm>
+            <a:off x="640080" y="3410712"/>
+            <a:ext cx="109728" cy="109728"/>
+          </a:xfrm>
+          <a:prstGeom prst="rect">
+            <a:avLst/>
+          </a:prstGeom>
+          <a:solidFill>
+            <a:srgbClr val="C45C26"/>
+          </a:solidFill>
+          <a:ln>
+            <a:noFill/>
+          </a:ln>
+        </p:spPr>
+        <p:style>
+          <a:lnRef idx="1">
+            <a:schemeClr val="accent1"/>
+          </a:lnRef>
+          <a:fillRef idx="3">
+            <a:schemeClr val="accent1"/>
+          </a:fillRef>
+          <a:effectRef idx="2">
+            <a:schemeClr val="accent1"/>
+          </a:effectRef>
+          <a:fontRef idx="minor">
+            <a:schemeClr val="lt1"/>
+          </a:fontRef>
+        </p:style>
+        <p:txBody>
+          <a:bodyPr rtlCol="0" anchor="ctr"/>
+          <a:lstStyle/>
+          <a:p>
+            <a:pPr algn="ctr"/>
+          </a:p>
+        </p:txBody>
+      </p:sp>
+      <p:sp>
+        <p:nvSpPr>
+          <p:cNvPr id="11" name="TextBox 10"/>
+          <p:cNvSpPr txBox="1"/>
+          <p:nvPr/>
+        </p:nvSpPr>
+        <p:spPr>
+          <a:xfrm>
+            <a:off x="960120" y="3300984"/>
+            <a:ext cx="10424160" cy="777240"/>
+          </a:xfrm>
+          <a:prstGeom prst="rect">
+            <a:avLst/>
+          </a:prstGeom>
+          <a:noFill/>
+        </p:spPr>
+        <p:txBody>
+          <a:bodyPr wrap="square">
+            <a:spAutoFit/>
+          </a:bodyPr>
+          <a:lstStyle/>
+          <a:p>
+            <a:pPr algn="l"/>
+            <a:r>
+              <a:rPr sz="1800" b="0">
+                <a:solidFill>
+                  <a:srgbClr val="1A1814"/>
+                </a:solidFill>
+                <a:latin typeface="Calibri"/>
                 <a:ea typeface="Calibri"/>
               </a:rPr>
-              <a:t>bootstrap\build.cmd</a:t>
-            </a:r>
-          </a:p>
-          <a:p>
-            <a:pPr>
-              <a:spcAft>
-                <a:spcPts val="800"/>
-              </a:spcAft>
-            </a:pPr>
-            <a:r>
-              <a:rPr sz="1600" b="0">
-                <a:solidFill>
-                  <a:srgbClr val="E8E0D0"/>
-                </a:solidFill>
-                <a:latin typeface="Consolas"/>
+              <a:t>The GitHub language bar needs a github-linguist PR. Threshold: at least 2000 public .kenga files in a year, not one account.</a:t>
+            </a:r>
+          </a:p>
+        </p:txBody>
+      </p:sp>
+      <p:sp>
+        <p:nvSpPr>
+          <p:cNvPr id="12" name="Rectangle 11"/>
+          <p:cNvSpPr/>
+          <p:nvPr/>
+        </p:nvSpPr>
+        <p:spPr>
+          <a:xfrm>
+            <a:off x="640080" y="4123944"/>
+            <a:ext cx="109728" cy="109728"/>
+          </a:xfrm>
+          <a:prstGeom prst="rect">
+            <a:avLst/>
+          </a:prstGeom>
+          <a:solidFill>
+            <a:srgbClr val="C45C26"/>
+          </a:solidFill>
+          <a:ln>
+            <a:noFill/>
+          </a:ln>
+        </p:spPr>
+        <p:style>
+          <a:lnRef idx="1">
+            <a:schemeClr val="accent1"/>
+          </a:lnRef>
+          <a:fillRef idx="3">
+            <a:schemeClr val="accent1"/>
+          </a:fillRef>
+          <a:effectRef idx="2">
+            <a:schemeClr val="accent1"/>
+          </a:effectRef>
+          <a:fontRef idx="minor">
+            <a:schemeClr val="lt1"/>
+          </a:fontRef>
+        </p:style>
+        <p:txBody>
+          <a:bodyPr rtlCol="0" anchor="ctr"/>
+          <a:lstStyle/>
+          <a:p>
+            <a:pPr algn="ctr"/>
+          </a:p>
+        </p:txBody>
+      </p:sp>
+      <p:sp>
+        <p:nvSpPr>
+          <p:cNvPr id="13" name="TextBox 12"/>
+          <p:cNvSpPr txBox="1"/>
+          <p:nvPr/>
+        </p:nvSpPr>
+        <p:spPr>
+          <a:xfrm>
+            <a:off x="960120" y="4014216"/>
+            <a:ext cx="10424160" cy="777240"/>
+          </a:xfrm>
+          <a:prstGeom prst="rect">
+            <a:avLst/>
+          </a:prstGeom>
+          <a:noFill/>
+        </p:spPr>
+        <p:txBody>
+          <a:bodyPr wrap="square">
+            <a:spAutoFit/>
+          </a:bodyPr>
+          <a:lstStyle/>
+          <a:p>
+            <a:pPr algn="l"/>
+            <a:r>
+              <a:rPr sz="1800" b="0">
+                <a:solidFill>
+                  <a:srgbClr val="1A1814"/>
+                </a:solidFill>
+                <a:latin typeface="Calibri"/>
                 <a:ea typeface="Calibri"/>
               </a:rPr>
-              <a:t>bootstrap\bin\kenga-lite.exe run examples\selfhost\fact_lite.kenga</a:t>
-            </a:r>
-          </a:p>
-          <a:p>
-            <a:pPr>
-              <a:spcAft>
-                <a:spcPts val="800"/>
-              </a:spcAft>
-            </a:pPr>
-            <a:r>
-              <a:rPr sz="1600" b="0">
-                <a:solidFill>
-                  <a:srgbClr val="E8E0D0"/>
-                </a:solidFill>
-                <a:latin typeface="Consolas"/>
-                <a:ea typeface="Calibri"/>
-              </a:rPr>
-              <a:t>scripts\freedom-smoke.cmd</a:t>
-            </a:r>
-          </a:p>
-        </p:txBody>
-      </p:sp>
-      <p:sp>
-        <p:nvSpPr>
-          <p:cNvPr id="8" name="TextBox 7"/>
+              <a:t>We do not open that PR yet. The grammar URL is ready when usage exists.</a:t>
+            </a:r>
+          </a:p>
+        </p:txBody>
+      </p:sp>
+      <p:sp>
+        <p:nvSpPr>
+          <p:cNvPr id="14" name="TextBox 13"/>
           <p:cNvSpPr txBox="1"/>
           <p:nvPr/>
         </p:nvSpPr>
@@ -8762,7 +9562,7 @@
       </p:sp>
       <p:sp>
         <p:nvSpPr>
-          <p:cNvPr id="9" name="TextBox 8"/>
+          <p:cNvPr id="15" name="TextBox 14"/>
           <p:cNvSpPr txBox="1"/>
           <p:nvPr/>
         </p:nvSpPr>
@@ -8791,7 +9591,7 @@
                 <a:latin typeface="Calibri"/>
                 <a:ea typeface="Calibri"/>
               </a:rPr>
-              <a:t>8 / 10</a:t>
+              <a:t>8 / 11</a:t>
             </a:r>
           </a:p>
         </p:txBody>
@@ -8931,7 +9731,7 @@
                 <a:latin typeface="Calibri"/>
                 <a:ea typeface="Calibri"/>
               </a:rPr>
-              <a:t>OFFER</a:t>
+              <a:t>REPRODUCE</a:t>
             </a:r>
           </a:p>
         </p:txBody>
@@ -8945,7 +9745,7 @@
         <p:spPr>
           <a:xfrm>
             <a:off x="640080" y="640080"/>
-            <a:ext cx="10972800" cy="1005840"/>
+            <a:ext cx="10972800" cy="822960"/>
           </a:xfrm>
           <a:prstGeom prst="rect">
             <a:avLst/>
@@ -8967,27 +9767,27 @@
                 <a:latin typeface="Calibri"/>
                 <a:ea typeface="Calibri"/>
               </a:rPr>
-              <a:t>License, four weeks, the host</a:t>
-            </a:r>
-          </a:p>
-        </p:txBody>
-      </p:sp>
-      <p:sp>
-        <p:nvSpPr>
-          <p:cNvPr id="6" name="Rectangle 5"/>
+              <a:t>Clone, build, run</a:t>
+            </a:r>
+          </a:p>
+        </p:txBody>
+      </p:sp>
+      <p:sp>
+        <p:nvSpPr>
+          <p:cNvPr id="6" name="Rounded Rectangle 5"/>
           <p:cNvSpPr/>
           <p:nvPr/>
         </p:nvSpPr>
         <p:spPr>
           <a:xfrm>
-            <a:off x="640080" y="1984248"/>
-            <a:ext cx="109728" cy="109728"/>
-          </a:xfrm>
-          <a:prstGeom prst="rect">
+            <a:off x="640080" y="1645920"/>
+            <a:ext cx="10881360" cy="4297680"/>
+          </a:xfrm>
+          <a:prstGeom prst="roundRect">
             <a:avLst/>
           </a:prstGeom>
           <a:solidFill>
-            <a:srgbClr val="C45C26"/>
+            <a:srgbClr val="1A1814"/>
           </a:solidFill>
           <a:ln>
             <a:noFill/>
@@ -9023,8 +9823,8 @@
         </p:nvSpPr>
         <p:spPr>
           <a:xfrm>
-            <a:off x="960120" y="1874519"/>
-            <a:ext cx="10424160" cy="777240"/>
+            <a:off x="914400" y="1874519"/>
+            <a:ext cx="10332720" cy="3931920"/>
           </a:xfrm>
           <a:prstGeom prst="rect">
             <a:avLst/>
@@ -9037,260 +9837,95 @@
           </a:bodyPr>
           <a:lstStyle/>
           <a:p>
-            <a:pPr algn="l"/>
-            <a:r>
-              <a:rPr sz="1800" b="0">
-                <a:solidFill>
-                  <a:srgbClr val="1A1814"/>
-                </a:solidFill>
-                <a:latin typeface="Calibri"/>
+            <a:pPr>
+              <a:spcAft>
+                <a:spcPts val="800"/>
+              </a:spcAft>
+            </a:pPr>
+            <a:r>
+              <a:rPr sz="1600" b="0">
+                <a:solidFill>
+                  <a:srgbClr val="E8E0D0"/>
+                </a:solidFill>
+                <a:latin typeface="Consolas"/>
                 <a:ea typeface="Calibri"/>
               </a:rPr>
-              <a:t>License the stack, or acquire it.</a:t>
-            </a:r>
-          </a:p>
-        </p:txBody>
-      </p:sp>
-      <p:sp>
-        <p:nvSpPr>
-          <p:cNvPr id="8" name="Rectangle 7"/>
-          <p:cNvSpPr/>
-          <p:nvPr/>
-        </p:nvSpPr>
-        <p:spPr>
-          <a:xfrm>
-            <a:off x="640080" y="2697480"/>
-            <a:ext cx="109728" cy="109728"/>
-          </a:xfrm>
-          <a:prstGeom prst="rect">
-            <a:avLst/>
-          </a:prstGeom>
-          <a:solidFill>
-            <a:srgbClr val="C45C26"/>
-          </a:solidFill>
-          <a:ln>
-            <a:noFill/>
-          </a:ln>
-        </p:spPr>
-        <p:style>
-          <a:lnRef idx="1">
-            <a:schemeClr val="accent1"/>
-          </a:lnRef>
-          <a:fillRef idx="3">
-            <a:schemeClr val="accent1"/>
-          </a:fillRef>
-          <a:effectRef idx="2">
-            <a:schemeClr val="accent1"/>
-          </a:effectRef>
-          <a:fontRef idx="minor">
-            <a:schemeClr val="lt1"/>
-          </a:fontRef>
-        </p:style>
-        <p:txBody>
-          <a:bodyPr rtlCol="0" anchor="ctr"/>
-          <a:lstStyle/>
-          <a:p>
-            <a:pPr algn="ctr"/>
-          </a:p>
-        </p:txBody>
-      </p:sp>
-      <p:sp>
-        <p:nvSpPr>
-          <p:cNvPr id="9" name="TextBox 8"/>
-          <p:cNvSpPr txBox="1"/>
-          <p:nvPr/>
-        </p:nvSpPr>
-        <p:spPr>
-          <a:xfrm>
-            <a:off x="960120" y="2587752"/>
-            <a:ext cx="10424160" cy="777240"/>
-          </a:xfrm>
-          <a:prstGeom prst="rect">
-            <a:avLst/>
-          </a:prstGeom>
-          <a:noFill/>
-        </p:spPr>
-        <p:txBody>
-          <a:bodyPr wrap="square">
-            <a:spAutoFit/>
-          </a:bodyPr>
-          <a:lstStyle/>
-          <a:p>
-            <a:pPr algn="l"/>
-            <a:r>
-              <a:rPr sz="1800" b="0">
-                <a:solidFill>
-                  <a:srgbClr val="1A1814"/>
-                </a:solidFill>
-                <a:latin typeface="Calibri"/>
+              <a:t>git clone https://github.com/GermannM3/kenga-lang.git</a:t>
+            </a:r>
+          </a:p>
+          <a:p>
+            <a:pPr>
+              <a:spcAft>
+                <a:spcPts val="800"/>
+              </a:spcAft>
+            </a:pPr>
+            <a:r>
+              <a:rPr sz="1600" b="0">
+                <a:solidFill>
+                  <a:srgbClr val="E8E0D0"/>
+                </a:solidFill>
+                <a:latin typeface="Consolas"/>
                 <a:ea typeface="Calibri"/>
               </a:rPr>
-              <a:t>A 4-week embed: you bring a language subset, we show compile and run on your machine.</a:t>
-            </a:r>
-          </a:p>
-        </p:txBody>
-      </p:sp>
-      <p:sp>
-        <p:nvSpPr>
-          <p:cNvPr id="10" name="Rectangle 9"/>
-          <p:cNvSpPr/>
-          <p:nvPr/>
-        </p:nvSpPr>
-        <p:spPr>
-          <a:xfrm>
-            <a:off x="640080" y="3410712"/>
-            <a:ext cx="109728" cy="109728"/>
-          </a:xfrm>
-          <a:prstGeom prst="rect">
-            <a:avLst/>
-          </a:prstGeom>
-          <a:solidFill>
-            <a:srgbClr val="C45C26"/>
-          </a:solidFill>
-          <a:ln>
-            <a:noFill/>
-          </a:ln>
-        </p:spPr>
-        <p:style>
-          <a:lnRef idx="1">
-            <a:schemeClr val="accent1"/>
-          </a:lnRef>
-          <a:fillRef idx="3">
-            <a:schemeClr val="accent1"/>
-          </a:fillRef>
-          <a:effectRef idx="2">
-            <a:schemeClr val="accent1"/>
-          </a:effectRef>
-          <a:fontRef idx="minor">
-            <a:schemeClr val="lt1"/>
-          </a:fontRef>
-        </p:style>
-        <p:txBody>
-          <a:bodyPr rtlCol="0" anchor="ctr"/>
-          <a:lstStyle/>
-          <a:p>
-            <a:pPr algn="ctr"/>
-          </a:p>
-        </p:txBody>
-      </p:sp>
-      <p:sp>
-        <p:nvSpPr>
-          <p:cNvPr id="11" name="TextBox 10"/>
-          <p:cNvSpPr txBox="1"/>
-          <p:nvPr/>
-        </p:nvSpPr>
-        <p:spPr>
-          <a:xfrm>
-            <a:off x="960120" y="3300984"/>
-            <a:ext cx="10424160" cy="777240"/>
-          </a:xfrm>
-          <a:prstGeom prst="rect">
-            <a:avLst/>
-          </a:prstGeom>
-          <a:noFill/>
-        </p:spPr>
-        <p:txBody>
-          <a:bodyPr wrap="square">
-            <a:spAutoFit/>
-          </a:bodyPr>
-          <a:lstStyle/>
-          <a:p>
-            <a:pPr algn="l"/>
-            <a:r>
-              <a:rPr sz="1800" b="0">
-                <a:solidFill>
-                  <a:srgbClr val="1A1814"/>
-                </a:solidFill>
-                <a:latin typeface="Calibri"/>
+              <a:t>cd kenga-lang</a:t>
+            </a:r>
+          </a:p>
+          <a:p>
+            <a:pPr>
+              <a:spcAft>
+                <a:spcPts val="800"/>
+              </a:spcAft>
+            </a:pPr>
+            <a:r>
+              <a:rPr sz="1600" b="0">
+                <a:solidFill>
+                  <a:srgbClr val="E8E0D0"/>
+                </a:solidFill>
+                <a:latin typeface="Consolas"/>
                 <a:ea typeface="Calibri"/>
               </a:rPr>
-              <a:t>An engineering partnership to replace more of the C host.</a:t>
-            </a:r>
-          </a:p>
-        </p:txBody>
-      </p:sp>
-      <p:sp>
-        <p:nvSpPr>
-          <p:cNvPr id="12" name="Rectangle 11"/>
-          <p:cNvSpPr/>
-          <p:nvPr/>
-        </p:nvSpPr>
-        <p:spPr>
-          <a:xfrm>
-            <a:off x="640080" y="4123944"/>
-            <a:ext cx="109728" cy="109728"/>
-          </a:xfrm>
-          <a:prstGeom prst="rect">
-            <a:avLst/>
-          </a:prstGeom>
-          <a:solidFill>
-            <a:srgbClr val="C45C26"/>
-          </a:solidFill>
-          <a:ln>
-            <a:noFill/>
-          </a:ln>
-        </p:spPr>
-        <p:style>
-          <a:lnRef idx="1">
-            <a:schemeClr val="accent1"/>
-          </a:lnRef>
-          <a:fillRef idx="3">
-            <a:schemeClr val="accent1"/>
-          </a:fillRef>
-          <a:effectRef idx="2">
-            <a:schemeClr val="accent1"/>
-          </a:effectRef>
-          <a:fontRef idx="minor">
-            <a:schemeClr val="lt1"/>
-          </a:fontRef>
-        </p:style>
-        <p:txBody>
-          <a:bodyPr rtlCol="0" anchor="ctr"/>
-          <a:lstStyle/>
-          <a:p>
-            <a:pPr algn="ctr"/>
-          </a:p>
-        </p:txBody>
-      </p:sp>
-      <p:sp>
-        <p:nvSpPr>
-          <p:cNvPr id="13" name="TextBox 12"/>
-          <p:cNvSpPr txBox="1"/>
-          <p:nvPr/>
-        </p:nvSpPr>
-        <p:spPr>
-          <a:xfrm>
-            <a:off x="960120" y="4014216"/>
-            <a:ext cx="10424160" cy="777240"/>
-          </a:xfrm>
-          <a:prstGeom prst="rect">
-            <a:avLst/>
-          </a:prstGeom>
-          <a:noFill/>
-        </p:spPr>
-        <p:txBody>
-          <a:bodyPr wrap="square">
-            <a:spAutoFit/>
-          </a:bodyPr>
-          <a:lstStyle/>
-          <a:p>
-            <a:pPr algn="l"/>
-            <a:r>
-              <a:rPr sz="1800" b="0">
-                <a:solidFill>
-                  <a:srgbClr val="1A1814"/>
-                </a:solidFill>
-                <a:latin typeface="Calibri"/>
+              <a:t>bootstrap\build.cmd</a:t>
+            </a:r>
+          </a:p>
+          <a:p>
+            <a:pPr>
+              <a:spcAft>
+                <a:spcPts val="800"/>
+              </a:spcAft>
+            </a:pPr>
+            <a:r>
+              <a:rPr sz="1600" b="0">
+                <a:solidFill>
+                  <a:srgbClr val="E8E0D0"/>
+                </a:solidFill>
+                <a:latin typeface="Consolas"/>
                 <a:ea typeface="Calibri"/>
               </a:rPr>
-              <a:t>The repo is already MIT. You pay for embed, for ownership, and for the remaining host work.</a:t>
-            </a:r>
-          </a:p>
-        </p:txBody>
-      </p:sp>
-      <p:sp>
-        <p:nvSpPr>
-          <p:cNvPr id="14" name="TextBox 13"/>
+              <a:t>bootstrap\bin\kenga-lite.exe run examples\selfhost\fact_lite.kenga</a:t>
+            </a:r>
+          </a:p>
+          <a:p>
+            <a:pPr>
+              <a:spcAft>
+                <a:spcPts val="800"/>
+              </a:spcAft>
+            </a:pPr>
+            <a:r>
+              <a:rPr sz="1600" b="0">
+                <a:solidFill>
+                  <a:srgbClr val="E8E0D0"/>
+                </a:solidFill>
+                <a:latin typeface="Consolas"/>
+                <a:ea typeface="Calibri"/>
+              </a:rPr>
+              <a:t>scripts\freedom-smoke.cmd</a:t>
+            </a:r>
+          </a:p>
+        </p:txBody>
+      </p:sp>
+      <p:sp>
+        <p:nvSpPr>
+          <p:cNvPr id="8" name="TextBox 7"/>
           <p:cNvSpPr txBox="1"/>
           <p:nvPr/>
         </p:nvSpPr>
@@ -9326,7 +9961,7 @@
       </p:sp>
       <p:sp>
         <p:nvSpPr>
-          <p:cNvPr id="15" name="TextBox 14"/>
+          <p:cNvPr id="9" name="TextBox 8"/>
           <p:cNvSpPr txBox="1"/>
           <p:nvPr/>
         </p:nvSpPr>
@@ -9355,7 +9990,7 @@
                 <a:latin typeface="Calibri"/>
                 <a:ea typeface="Calibri"/>
               </a:rPr>
-              <a:t>9 / 10</a:t>
+              <a:t>9 / 11</a:t>
             </a:r>
           </a:p>
         </p:txBody>

</xml_diff>